<commit_message>
Updated pptx and gui.pyw
</commit_message>
<xml_diff>
--- a/docs/SmartAttendance.pptx
+++ b/docs/SmartAttendance.pptx
@@ -20,22 +20,29 @@
   <p:notesSz cx="6858000" cy="9144000"/>
   <p:embeddedFontLst>
     <p:embeddedFont>
-      <p:font typeface="Montserrat"/>
+      <p:font typeface="Montserrat SemiBold"/>
       <p:regular r:id="rId13"/>
       <p:bold r:id="rId14"/>
       <p:italic r:id="rId15"/>
       <p:boldItalic r:id="rId16"/>
     </p:embeddedFont>
     <p:embeddedFont>
-      <p:font typeface="Vidaloka"/>
+      <p:font typeface="Montserrat"/>
       <p:regular r:id="rId17"/>
+      <p:bold r:id="rId18"/>
+      <p:italic r:id="rId19"/>
+      <p:boldItalic r:id="rId20"/>
     </p:embeddedFont>
     <p:embeddedFont>
-      <p:font typeface="Quattrocento Sans"/>
-      <p:regular r:id="rId18"/>
-      <p:bold r:id="rId19"/>
-      <p:italic r:id="rId20"/>
-      <p:boldItalic r:id="rId21"/>
+      <p:font typeface="Montserrat Medium"/>
+      <p:regular r:id="rId21"/>
+      <p:bold r:id="rId22"/>
+      <p:italic r:id="rId23"/>
+      <p:boldItalic r:id="rId24"/>
+    </p:embeddedFont>
+    <p:embeddedFont>
+      <p:font typeface="Vidaloka"/>
+      <p:regular r:id="rId25"/>
     </p:embeddedFont>
   </p:embeddedFontLst>
   <p:defaultTextStyle>
@@ -1086,7 +1093,7 @@
   <p:cSld>
     <p:spTree>
       <p:nvGrpSpPr>
-        <p:cNvPr id="73" name="Shape 73"/>
+        <p:cNvPr id="72" name="Shape 72"/>
         <p:cNvGrpSpPr/>
         <p:nvPr/>
       </p:nvGrpSpPr>
@@ -1100,7 +1107,7 @@
       </p:grpSpPr>
       <p:sp>
         <p:nvSpPr>
-          <p:cNvPr id="74" name="Google Shape;74;p3:notes"/>
+          <p:cNvPr id="73" name="Google Shape;73;p3:notes"/>
           <p:cNvSpPr/>
           <p:nvPr>
             <p:ph idx="2" type="sldImg"/>
@@ -1145,7 +1152,7 @@
       </p:sp>
       <p:sp>
         <p:nvSpPr>
-          <p:cNvPr id="75" name="Google Shape;75;p3:notes"/>
+          <p:cNvPr id="74" name="Google Shape;74;p3:notes"/>
           <p:cNvSpPr txBox="1"/>
           <p:nvPr>
             <p:ph idx="1" type="body"/>
@@ -1203,7 +1210,7 @@
   <p:cSld>
     <p:spTree>
       <p:nvGrpSpPr>
-        <p:cNvPr id="81" name="Shape 81"/>
+        <p:cNvPr id="80" name="Shape 80"/>
         <p:cNvGrpSpPr/>
         <p:nvPr/>
       </p:nvGrpSpPr>
@@ -1217,7 +1224,7 @@
       </p:grpSpPr>
       <p:sp>
         <p:nvSpPr>
-          <p:cNvPr id="82" name="Google Shape;82;p4:notes"/>
+          <p:cNvPr id="81" name="Google Shape;81;p4:notes"/>
           <p:cNvSpPr/>
           <p:nvPr>
             <p:ph idx="2" type="sldImg"/>
@@ -1262,7 +1269,7 @@
       </p:sp>
       <p:sp>
         <p:nvSpPr>
-          <p:cNvPr id="83" name="Google Shape;83;p4:notes"/>
+          <p:cNvPr id="82" name="Google Shape;82;p4:notes"/>
           <p:cNvSpPr txBox="1"/>
           <p:nvPr>
             <p:ph idx="1" type="body"/>
@@ -1320,7 +1327,7 @@
   <p:cSld>
     <p:spTree>
       <p:nvGrpSpPr>
-        <p:cNvPr id="89" name="Shape 89"/>
+        <p:cNvPr id="88" name="Shape 88"/>
         <p:cNvGrpSpPr/>
         <p:nvPr/>
       </p:nvGrpSpPr>
@@ -1334,7 +1341,7 @@
       </p:grpSpPr>
       <p:sp>
         <p:nvSpPr>
-          <p:cNvPr id="90" name="Google Shape;90;p5:notes"/>
+          <p:cNvPr id="89" name="Google Shape;89;p5:notes"/>
           <p:cNvSpPr/>
           <p:nvPr>
             <p:ph idx="2" type="sldImg"/>
@@ -1379,7 +1386,7 @@
       </p:sp>
       <p:sp>
         <p:nvSpPr>
-          <p:cNvPr id="91" name="Google Shape;91;p5:notes"/>
+          <p:cNvPr id="90" name="Google Shape;90;p5:notes"/>
           <p:cNvSpPr txBox="1"/>
           <p:nvPr>
             <p:ph idx="1" type="body"/>
@@ -1426,7 +1433,7 @@
       </p:sp>
       <p:sp>
         <p:nvSpPr>
-          <p:cNvPr id="92" name="Google Shape;92;p5:notes"/>
+          <p:cNvPr id="91" name="Google Shape;91;p5:notes"/>
           <p:cNvSpPr txBox="1"/>
           <p:nvPr>
             <p:ph idx="12" type="sldNum"/>
@@ -1505,7 +1512,7 @@
   <p:cSld>
     <p:spTree>
       <p:nvGrpSpPr>
-        <p:cNvPr id="100" name="Shape 100"/>
+        <p:cNvPr id="99" name="Shape 99"/>
         <p:cNvGrpSpPr/>
         <p:nvPr/>
       </p:nvGrpSpPr>
@@ -1519,7 +1526,7 @@
       </p:grpSpPr>
       <p:sp>
         <p:nvSpPr>
-          <p:cNvPr id="101" name="Google Shape;101;p6:notes"/>
+          <p:cNvPr id="100" name="Google Shape;100;p6:notes"/>
           <p:cNvSpPr/>
           <p:nvPr>
             <p:ph idx="2" type="sldImg"/>
@@ -1564,7 +1571,7 @@
       </p:sp>
       <p:sp>
         <p:nvSpPr>
-          <p:cNvPr id="102" name="Google Shape;102;p6:notes"/>
+          <p:cNvPr id="101" name="Google Shape;101;p6:notes"/>
           <p:cNvSpPr txBox="1"/>
           <p:nvPr>
             <p:ph idx="1" type="body"/>
@@ -1611,7 +1618,7 @@
       </p:sp>
       <p:sp>
         <p:nvSpPr>
-          <p:cNvPr id="103" name="Google Shape;103;p6:notes"/>
+          <p:cNvPr id="102" name="Google Shape;102;p6:notes"/>
           <p:cNvSpPr txBox="1"/>
           <p:nvPr>
             <p:ph idx="12" type="sldNum"/>
@@ -1690,7 +1697,7 @@
   <p:cSld>
     <p:spTree>
       <p:nvGrpSpPr>
-        <p:cNvPr id="108" name="Shape 108"/>
+        <p:cNvPr id="107" name="Shape 107"/>
         <p:cNvGrpSpPr/>
         <p:nvPr/>
       </p:nvGrpSpPr>
@@ -1704,7 +1711,7 @@
       </p:grpSpPr>
       <p:sp>
         <p:nvSpPr>
-          <p:cNvPr id="109" name="Google Shape;109;p7:notes"/>
+          <p:cNvPr id="108" name="Google Shape;108;p7:notes"/>
           <p:cNvSpPr/>
           <p:nvPr>
             <p:ph idx="2" type="sldImg"/>
@@ -1749,7 +1756,7 @@
       </p:sp>
       <p:sp>
         <p:nvSpPr>
-          <p:cNvPr id="110" name="Google Shape;110;p7:notes"/>
+          <p:cNvPr id="109" name="Google Shape;109;p7:notes"/>
           <p:cNvSpPr txBox="1"/>
           <p:nvPr>
             <p:ph idx="1" type="body"/>
@@ -5763,14 +5770,12 @@
         <p:nvSpPr>
           <p:cNvPr id="63" name="Google Shape;63;p12"/>
           <p:cNvSpPr txBox="1"/>
-          <p:nvPr>
-            <p:ph type="ctrTitle"/>
-          </p:nvPr>
+          <p:nvPr/>
         </p:nvSpPr>
         <p:spPr>
           <a:xfrm>
-            <a:off x="1039974" y="2350800"/>
-            <a:ext cx="7064100" cy="2052600"/>
+            <a:off x="1939650" y="840150"/>
+            <a:ext cx="5264700" cy="3463200"/>
           </a:xfrm>
           <a:prstGeom prst="rect">
             <a:avLst/>
@@ -5781,15 +5786,12 @@
           </a:ln>
         </p:spPr>
         <p:txBody>
-          <a:bodyPr anchorCtr="0" anchor="b" bIns="91425" lIns="91425" spcFirstLastPara="1" rIns="91425" wrap="square" tIns="91425">
-            <a:noAutofit/>
+          <a:bodyPr anchorCtr="0" anchor="t" bIns="91425" lIns="91425" spcFirstLastPara="1" rIns="91425" wrap="square" tIns="91425">
+            <a:spAutoFit/>
           </a:bodyPr>
           <a:lstStyle/>
           <a:p>
-            <a:pPr indent="0" lvl="0" marL="0" marR="0" rtl="0" algn="ctr">
-              <a:lnSpc>
-                <a:spcPct val="100000"/>
-              </a:lnSpc>
+            <a:pPr indent="0" lvl="0" marL="0" rtl="0" algn="ctr">
               <a:spcBef>
                 <a:spcPts val="0"/>
               </a:spcBef>
@@ -5804,45 +5806,49 @@
               <a:buNone/>
             </a:pPr>
             <a:r>
-              <a:rPr b="0" i="0" lang="az-Latn-AZ" sz="6500" u="none" cap="none" strike="noStrike">
+              <a:rPr b="1" lang="az-Latn-AZ" sz="6500">
                 <a:solidFill>
                   <a:schemeClr val="dk1"/>
                 </a:solidFill>
-                <a:latin typeface="Vidaloka"/>
-                <a:ea typeface="Vidaloka"/>
-                <a:cs typeface="Vidaloka"/>
-                <a:sym typeface="Vidaloka"/>
+                <a:latin typeface="Montserrat"/>
+                <a:ea typeface="Montserrat"/>
+                <a:cs typeface="Montserrat"/>
+                <a:sym typeface="Montserrat"/>
               </a:rPr>
               <a:t>Ağıllı davamiyyət sistemi</a:t>
             </a:r>
-            <a:endParaRPr b="0" i="0" sz="6500" u="none" cap="none" strike="noStrike">
+            <a:endParaRPr b="1" sz="6500">
               <a:solidFill>
                 <a:schemeClr val="dk1"/>
               </a:solidFill>
-              <a:latin typeface="Vidaloka"/>
-              <a:ea typeface="Vidaloka"/>
-              <a:cs typeface="Vidaloka"/>
-              <a:sym typeface="Vidaloka"/>
+              <a:latin typeface="Montserrat"/>
+              <a:ea typeface="Montserrat"/>
+              <a:cs typeface="Montserrat"/>
+              <a:sym typeface="Montserrat"/>
             </a:endParaRPr>
           </a:p>
           <a:p>
-            <a:pPr indent="0" lvl="0" marL="0" rtl="0" algn="ctr">
-              <a:lnSpc>
-                <a:spcPct val="100000"/>
-              </a:lnSpc>
-              <a:spcBef>
-                <a:spcPts val="0"/>
-              </a:spcBef>
-              <a:spcAft>
-                <a:spcPts val="0"/>
-              </a:spcAft>
-              <a:buSzPts val="5200"/>
+            <a:pPr indent="0" lvl="0" marL="0" rtl="0" algn="l">
+              <a:spcBef>
+                <a:spcPts val="0"/>
+              </a:spcBef>
+              <a:spcAft>
+                <a:spcPts val="0"/>
+              </a:spcAft>
               <a:buNone/>
             </a:pPr>
             <a:r>
               <a:t/>
             </a:r>
-            <a:endParaRPr/>
+            <a:endParaRPr sz="1800">
+              <a:solidFill>
+                <a:schemeClr val="dk2"/>
+              </a:solidFill>
+              <a:latin typeface="Montserrat"/>
+              <a:ea typeface="Montserrat"/>
+              <a:cs typeface="Montserrat"/>
+              <a:sym typeface="Montserrat"/>
+            </a:endParaRPr>
           </a:p>
         </p:txBody>
       </p:sp>
@@ -5881,8 +5887,8 @@
         </p:nvSpPr>
         <p:spPr>
           <a:xfrm>
-            <a:off x="0" y="959999"/>
-            <a:ext cx="4465800" cy="3874841"/>
+            <a:off x="0" y="1219975"/>
+            <a:ext cx="4465800" cy="3499200"/>
           </a:xfrm>
           <a:prstGeom prst="rect">
             <a:avLst/>
@@ -5916,37 +5922,25 @@
               <a:buChar char="•"/>
             </a:pPr>
             <a:r>
-              <a:rPr b="0" i="0" lang="az-Latn-AZ" sz="1800" u="none">
-                <a:solidFill>
-                  <a:srgbClr val="000000"/>
-                </a:solidFill>
-                <a:latin typeface="Times New Roman"/>
-                <a:ea typeface="Times New Roman"/>
-                <a:cs typeface="Times New Roman"/>
-                <a:sym typeface="Times New Roman"/>
-              </a:rPr>
-              <a:t> </a:t>
-            </a:r>
-            <a:r>
-              <a:rPr b="0" i="0" lang="az-Latn-AZ" sz="2200" u="none" cap="none" strike="noStrike">
+              <a:rPr i="0" lang="az-Latn-AZ" sz="2000" u="none" cap="none" strike="noStrike">
                 <a:solidFill>
                   <a:schemeClr val="dk1"/>
                 </a:solidFill>
-                <a:latin typeface="Vidaloka"/>
-                <a:ea typeface="Vidaloka"/>
-                <a:cs typeface="Vidaloka"/>
-                <a:sym typeface="Vidaloka"/>
+                <a:latin typeface="Montserrat Medium"/>
+                <a:ea typeface="Montserrat Medium"/>
+                <a:cs typeface="Montserrat Medium"/>
+                <a:sym typeface="Montserrat Medium"/>
               </a:rPr>
               <a:t>Bu, müasir üz tanıma texnologiyasına əsaslanan proqram təminatıdır. Sistem, yüksək dəqiqlikli kameralar vasitəsilə insan simalarını skan edərək biometrik məlumatları emal edir və saniyələr ərzində şəxsin kimliyini müəyyənləşdirməyə imkan verir.</a:t>
             </a:r>
-            <a:endParaRPr b="0" i="0" sz="2200" u="none" cap="none" strike="noStrike">
+            <a:endParaRPr i="0" sz="2000" u="none" cap="none" strike="noStrike">
               <a:solidFill>
                 <a:schemeClr val="dk1"/>
               </a:solidFill>
-              <a:latin typeface="Vidaloka"/>
-              <a:ea typeface="Vidaloka"/>
-              <a:cs typeface="Vidaloka"/>
-              <a:sym typeface="Vidaloka"/>
+              <a:latin typeface="Montserrat Medium"/>
+              <a:ea typeface="Montserrat Medium"/>
+              <a:cs typeface="Montserrat Medium"/>
+              <a:sym typeface="Montserrat Medium"/>
             </a:endParaRPr>
           </a:p>
           <a:p>
@@ -5970,11 +5964,11 @@
             <a:r>
               <a:t/>
             </a:r>
-            <a:endParaRPr sz="1100">
-              <a:latin typeface="Quattrocento Sans"/>
-              <a:ea typeface="Quattrocento Sans"/>
-              <a:cs typeface="Quattrocento Sans"/>
-              <a:sym typeface="Quattrocento Sans"/>
+            <a:endParaRPr sz="900">
+              <a:latin typeface="Montserrat Medium"/>
+              <a:ea typeface="Montserrat Medium"/>
+              <a:cs typeface="Montserrat Medium"/>
+              <a:sym typeface="Montserrat Medium"/>
             </a:endParaRPr>
           </a:p>
         </p:txBody>
@@ -6020,10 +6014,20 @@
               <a:buNone/>
             </a:pPr>
             <a:r>
-              <a:rPr lang="az-Latn-AZ"/>
+              <a:rPr b="1" lang="az-Latn-AZ">
+                <a:latin typeface="Montserrat"/>
+                <a:ea typeface="Montserrat"/>
+                <a:cs typeface="Montserrat"/>
+                <a:sym typeface="Montserrat"/>
+              </a:rPr>
               <a:t>Ağıllı davamiyyət sistemi tam olaraq nədir?</a:t>
             </a:r>
-            <a:endParaRPr/>
+            <a:endParaRPr b="1">
+              <a:latin typeface="Montserrat"/>
+              <a:ea typeface="Montserrat"/>
+              <a:cs typeface="Montserrat"/>
+              <a:sym typeface="Montserrat"/>
+            </a:endParaRPr>
           </a:p>
         </p:txBody>
       </p:sp>
@@ -6035,8 +6039,298 @@
         </p:nvSpPr>
         <p:spPr>
           <a:xfrm>
-            <a:off x="4321116" y="1022052"/>
-            <a:ext cx="3880500" cy="461700"/>
+            <a:off x="4465800" y="1219974"/>
+            <a:ext cx="3742800" cy="2031900"/>
+          </a:xfrm>
+          <a:prstGeom prst="rect">
+            <a:avLst/>
+          </a:prstGeom>
+          <a:noFill/>
+          <a:ln>
+            <a:noFill/>
+          </a:ln>
+        </p:spPr>
+        <p:txBody>
+          <a:bodyPr anchorCtr="0" anchor="t" bIns="91425" lIns="91425" spcFirstLastPara="1" rIns="91425" wrap="square" tIns="91425">
+            <a:spAutoFit/>
+          </a:bodyPr>
+          <a:lstStyle/>
+          <a:p>
+            <a:pPr indent="0" lvl="0" marL="0" marR="0" rtl="0" algn="l">
+              <a:lnSpc>
+                <a:spcPct val="100000"/>
+              </a:lnSpc>
+              <a:spcBef>
+                <a:spcPts val="0"/>
+              </a:spcBef>
+              <a:spcAft>
+                <a:spcPts val="0"/>
+              </a:spcAft>
+              <a:buNone/>
+            </a:pPr>
+            <a:r>
+              <a:rPr lang="az-Latn-AZ" sz="2000">
+                <a:solidFill>
+                  <a:schemeClr val="dk2"/>
+                </a:solidFill>
+                <a:latin typeface="Montserrat Medium"/>
+                <a:ea typeface="Montserrat Medium"/>
+                <a:cs typeface="Montserrat Medium"/>
+                <a:sym typeface="Montserrat Medium"/>
+              </a:rPr>
+              <a:t>Bu vasitə ilə istifadəçilərin giriş-çıxış məlumatları avtomoatik olaraq qeydə alınır və idarəetmə panelində anlıq olaraq izlənilə bilir.</a:t>
+            </a:r>
+            <a:endParaRPr i="0" sz="2000" u="none" cap="none" strike="noStrike">
+              <a:solidFill>
+                <a:schemeClr val="dk2"/>
+              </a:solidFill>
+              <a:latin typeface="Montserrat Medium"/>
+              <a:ea typeface="Montserrat Medium"/>
+              <a:cs typeface="Montserrat Medium"/>
+              <a:sym typeface="Montserrat Medium"/>
+            </a:endParaRPr>
+          </a:p>
+        </p:txBody>
+      </p:sp>
+      <p:sp>
+        <p:nvSpPr>
+          <p:cNvPr id="71" name="Google Shape;71;p13"/>
+          <p:cNvSpPr txBox="1"/>
+          <p:nvPr/>
+        </p:nvSpPr>
+        <p:spPr>
+          <a:xfrm>
+            <a:off x="242961" y="3219208"/>
+            <a:ext cx="3497250" cy="335639"/>
+          </a:xfrm>
+          <a:prstGeom prst="rect">
+            <a:avLst/>
+          </a:prstGeom>
+          <a:noFill/>
+          <a:ln>
+            <a:noFill/>
+          </a:ln>
+        </p:spPr>
+        <p:txBody>
+          <a:bodyPr anchorCtr="0" anchor="t" bIns="45700" lIns="91425" spcFirstLastPara="1" rIns="91425" wrap="square" tIns="45700">
+            <a:spAutoFit/>
+          </a:bodyPr>
+          <a:lstStyle/>
+          <a:p>
+            <a:pPr indent="0" lvl="0" marL="0" marR="0" rtl="0" algn="l">
+              <a:lnSpc>
+                <a:spcPct val="100000"/>
+              </a:lnSpc>
+              <a:spcBef>
+                <a:spcPts val="0"/>
+              </a:spcBef>
+              <a:spcAft>
+                <a:spcPts val="0"/>
+              </a:spcAft>
+              <a:buClr>
+                <a:srgbClr val="000000"/>
+              </a:buClr>
+              <a:buSzPts val="1600"/>
+              <a:buFont typeface="Arial"/>
+              <a:buNone/>
+            </a:pPr>
+            <a:r>
+              <a:t/>
+            </a:r>
+            <a:endParaRPr b="0" i="0" sz="1600" u="none" cap="none" strike="noStrike">
+              <a:solidFill>
+                <a:srgbClr val="000000"/>
+              </a:solidFill>
+              <a:latin typeface="Arial"/>
+              <a:ea typeface="Arial"/>
+              <a:cs typeface="Arial"/>
+              <a:sym typeface="Arial"/>
+            </a:endParaRPr>
+          </a:p>
+        </p:txBody>
+      </p:sp>
+    </p:spTree>
+  </p:cSld>
+  <p:clrMapOvr>
+    <a:masterClrMapping/>
+  </p:clrMapOvr>
+</p:sld>
+</file>
+
+<file path=ppt/slides/slide3.xml><?xml version="1.0" encoding="utf-8"?>
+<p:sld xmlns:a="http://schemas.openxmlformats.org/drawingml/2006/main" xmlns:r="http://schemas.openxmlformats.org/officeDocument/2006/relationships" xmlns:mc="http://schemas.openxmlformats.org/markup-compatibility/2006" xmlns:mv="urn:schemas-microsoft-com:mac:vml" xmlns:p="http://schemas.openxmlformats.org/presentationml/2006/main" xmlns:c="http://schemas.openxmlformats.org/drawingml/2006/chart" xmlns:dgm="http://schemas.openxmlformats.org/drawingml/2006/diagram" xmlns:o="urn:schemas-microsoft-com:office:office" xmlns:v="urn:schemas-microsoft-com:vml" xmlns:pvml="urn:schemas-microsoft-com:office:powerpoint" xmlns:com="http://schemas.openxmlformats.org/drawingml/2006/compatibility" xmlns:p14="http://schemas.microsoft.com/office/powerpoint/2010/main" xmlns:p15="http://schemas.microsoft.com/office/powerpoint/2012/main" xmlns:ahyp="http://schemas.microsoft.com/office/drawing/2018/hyperlinkcolor">
+  <p:cSld>
+    <p:spTree>
+      <p:nvGrpSpPr>
+        <p:cNvPr id="75" name="Shape 75"/>
+        <p:cNvGrpSpPr/>
+        <p:nvPr/>
+      </p:nvGrpSpPr>
+      <p:grpSpPr>
+        <a:xfrm>
+          <a:off x="0" y="0"/>
+          <a:ext cx="0" cy="0"/>
+          <a:chOff x="0" y="0"/>
+          <a:chExt cx="0" cy="0"/>
+        </a:xfrm>
+      </p:grpSpPr>
+      <p:sp>
+        <p:nvSpPr>
+          <p:cNvPr id="76" name="Google Shape;76;p14"/>
+          <p:cNvSpPr txBox="1"/>
+          <p:nvPr>
+            <p:ph idx="1" type="subTitle"/>
+          </p:nvPr>
+        </p:nvSpPr>
+        <p:spPr>
+          <a:xfrm>
+            <a:off x="-1" y="845926"/>
+            <a:ext cx="4572000" cy="2640300"/>
+          </a:xfrm>
+          <a:prstGeom prst="rect">
+            <a:avLst/>
+          </a:prstGeom>
+          <a:noFill/>
+          <a:ln>
+            <a:noFill/>
+          </a:ln>
+        </p:spPr>
+        <p:txBody>
+          <a:bodyPr anchorCtr="0" anchor="t" bIns="91400" lIns="91400" spcFirstLastPara="1" rIns="91400" wrap="square" tIns="91400">
+            <a:noAutofit/>
+          </a:bodyPr>
+          <a:lstStyle/>
+          <a:p>
+            <a:pPr indent="-292100" lvl="0" marL="457200" rtl="0" algn="l">
+              <a:lnSpc>
+                <a:spcPct val="100000"/>
+              </a:lnSpc>
+              <a:spcBef>
+                <a:spcPts val="0"/>
+              </a:spcBef>
+              <a:spcAft>
+                <a:spcPts val="0"/>
+              </a:spcAft>
+              <a:buClr>
+                <a:schemeClr val="dk1"/>
+              </a:buClr>
+              <a:buSzPts val="2200"/>
+              <a:buFont typeface="Arial"/>
+              <a:buChar char="•"/>
+            </a:pPr>
+            <a:r>
+              <a:rPr i="0" lang="az-Latn-AZ" sz="2200" u="none">
+                <a:solidFill>
+                  <a:srgbClr val="000000"/>
+                </a:solidFill>
+                <a:latin typeface="Montserrat Medium"/>
+                <a:ea typeface="Montserrat Medium"/>
+                <a:cs typeface="Montserrat Medium"/>
+                <a:sym typeface="Montserrat Medium"/>
+              </a:rPr>
+              <a:t> </a:t>
+            </a:r>
+            <a:r>
+              <a:rPr i="0" lang="az-Latn-AZ" sz="2200" u="none" cap="none" strike="noStrike">
+                <a:solidFill>
+                  <a:schemeClr val="dk1"/>
+                </a:solidFill>
+                <a:latin typeface="Montserrat Medium"/>
+                <a:ea typeface="Montserrat Medium"/>
+                <a:cs typeface="Montserrat Medium"/>
+                <a:sym typeface="Montserrat Medium"/>
+              </a:rPr>
+              <a:t>Biz bu sistemi tətbiq etməkdə əsas məqsədimiz, şagirdlərin dərsə iştirakının qeydiyyat prosesini tamamilə avtomatlaşdırmaq və bununla da məktəb heyətinin inzibati yükünü əhəmiyyətli dərəcədə azaltmaqdır</a:t>
+            </a:r>
+            <a:r>
+              <a:rPr i="0" lang="az-Latn-AZ" sz="2200" u="none">
+                <a:solidFill>
+                  <a:srgbClr val="000000"/>
+                </a:solidFill>
+                <a:latin typeface="Montserrat Medium"/>
+                <a:ea typeface="Montserrat Medium"/>
+                <a:cs typeface="Montserrat Medium"/>
+                <a:sym typeface="Montserrat Medium"/>
+              </a:rPr>
+              <a:t>.</a:t>
+            </a:r>
+            <a:endParaRPr sz="2200">
+              <a:latin typeface="Montserrat Medium"/>
+              <a:ea typeface="Montserrat Medium"/>
+              <a:cs typeface="Montserrat Medium"/>
+              <a:sym typeface="Montserrat Medium"/>
+            </a:endParaRPr>
+          </a:p>
+        </p:txBody>
+      </p:sp>
+      <p:sp>
+        <p:nvSpPr>
+          <p:cNvPr id="77" name="Google Shape;77;p14"/>
+          <p:cNvSpPr txBox="1"/>
+          <p:nvPr>
+            <p:ph type="title"/>
+          </p:nvPr>
+        </p:nvSpPr>
+        <p:spPr>
+          <a:xfrm>
+            <a:off x="0" y="273225"/>
+            <a:ext cx="9144000" cy="572700"/>
+          </a:xfrm>
+          <a:prstGeom prst="rect">
+            <a:avLst/>
+          </a:prstGeom>
+          <a:noFill/>
+          <a:ln>
+            <a:noFill/>
+          </a:ln>
+        </p:spPr>
+        <p:txBody>
+          <a:bodyPr anchorCtr="0" anchor="t" bIns="91425" lIns="91425" spcFirstLastPara="1" rIns="91425" wrap="square" tIns="91425">
+            <a:noAutofit/>
+          </a:bodyPr>
+          <a:lstStyle/>
+          <a:p>
+            <a:pPr indent="0" lvl="0" marL="0" rtl="0" algn="ctr">
+              <a:lnSpc>
+                <a:spcPct val="100000"/>
+              </a:lnSpc>
+              <a:spcBef>
+                <a:spcPts val="0"/>
+              </a:spcBef>
+              <a:spcAft>
+                <a:spcPts val="0"/>
+              </a:spcAft>
+              <a:buSzPts val="3000"/>
+              <a:buNone/>
+            </a:pPr>
+            <a:r>
+              <a:rPr b="1" lang="az-Latn-AZ">
+                <a:latin typeface="Montserrat"/>
+                <a:ea typeface="Montserrat"/>
+                <a:cs typeface="Montserrat"/>
+                <a:sym typeface="Montserrat"/>
+              </a:rPr>
+              <a:t>Biz bunu niyə edirik?</a:t>
+            </a:r>
+            <a:endParaRPr b="1">
+              <a:latin typeface="Montserrat"/>
+              <a:ea typeface="Montserrat"/>
+              <a:cs typeface="Montserrat"/>
+              <a:sym typeface="Montserrat"/>
+            </a:endParaRPr>
+          </a:p>
+        </p:txBody>
+      </p:sp>
+      <p:sp>
+        <p:nvSpPr>
+          <p:cNvPr id="78" name="Google Shape;78;p14"/>
+          <p:cNvSpPr txBox="1"/>
+          <p:nvPr/>
+        </p:nvSpPr>
+        <p:spPr>
+          <a:xfrm>
+            <a:off x="5618450" y="1212625"/>
+            <a:ext cx="3546900" cy="461700"/>
           </a:xfrm>
           <a:prstGeom prst="rect">
             <a:avLst/>
@@ -6086,14 +6380,14 @@
       </p:sp>
       <p:sp>
         <p:nvSpPr>
-          <p:cNvPr id="71" name="Google Shape;71;p13"/>
+          <p:cNvPr id="79" name="Google Shape;79;p14"/>
           <p:cNvSpPr txBox="1"/>
           <p:nvPr/>
         </p:nvSpPr>
         <p:spPr>
           <a:xfrm>
-            <a:off x="242961" y="3219208"/>
-            <a:ext cx="3497250" cy="335639"/>
+            <a:off x="4572000" y="845925"/>
+            <a:ext cx="3983100" cy="2986200"/>
           </a:xfrm>
           <a:prstGeom prst="rect">
             <a:avLst/>
@@ -6109,331 +6403,43 @@
           </a:bodyPr>
           <a:lstStyle/>
           <a:p>
-            <a:pPr indent="0" lvl="0" marL="0" marR="0" rtl="0" algn="l">
-              <a:lnSpc>
-                <a:spcPct val="100000"/>
-              </a:lnSpc>
-              <a:spcBef>
-                <a:spcPts val="0"/>
-              </a:spcBef>
-              <a:spcAft>
-                <a:spcPts val="0"/>
-              </a:spcAft>
-              <a:buNone/>
+            <a:pPr indent="-368300" lvl="0" marL="457200" marR="0" rtl="0" algn="l">
+              <a:lnSpc>
+                <a:spcPct val="100000"/>
+              </a:lnSpc>
+              <a:spcBef>
+                <a:spcPts val="0"/>
+              </a:spcBef>
+              <a:spcAft>
+                <a:spcPts val="0"/>
+              </a:spcAft>
+              <a:buClr>
+                <a:schemeClr val="dk1"/>
+              </a:buClr>
+              <a:buSzPts val="3400"/>
+              <a:buFont typeface="Montserrat Medium"/>
+              <a:buChar char="•"/>
             </a:pPr>
             <a:r>
-              <a:t/>
+              <a:rPr i="0" lang="az-Latn-AZ" sz="2200" u="none" cap="none" strike="noStrike">
+                <a:solidFill>
+                  <a:srgbClr val="000000"/>
+                </a:solidFill>
+                <a:latin typeface="Montserrat Medium"/>
+                <a:ea typeface="Montserrat Medium"/>
+                <a:cs typeface="Montserrat Medium"/>
+                <a:sym typeface="Montserrat Medium"/>
+              </a:rPr>
+              <a:t>Bu ağıllı proqram təminatı ilə məktəbiniz daha təhlükəsiz, müəllimlər isə daha az yüklənmiş olacaq! jurnal yazmaq üçün sərf olunan vaxt isə xeyli qısalır. </a:t>
             </a:r>
-            <a:endParaRPr b="0" i="0" sz="1600" u="none" cap="none" strike="noStrike">
+            <a:endParaRPr i="0" sz="2200" u="none" cap="none" strike="noStrike">
               <a:solidFill>
                 <a:srgbClr val="000000"/>
               </a:solidFill>
-              <a:latin typeface="Arial"/>
-              <a:ea typeface="Arial"/>
-              <a:cs typeface="Arial"/>
-              <a:sym typeface="Arial"/>
-            </a:endParaRPr>
-          </a:p>
-        </p:txBody>
-      </p:sp>
-      <p:pic>
-        <p:nvPicPr>
-          <p:cNvPr id="72" name="Google Shape;72;p13"/>
-          <p:cNvPicPr preferRelativeResize="0"/>
-          <p:nvPr/>
-        </p:nvPicPr>
-        <p:blipFill rotWithShape="1">
-          <a:blip r:embed="rId3">
-            <a:alphaModFix/>
-          </a:blip>
-          <a:srcRect b="0" l="0" r="0" t="0"/>
-          <a:stretch/>
-        </p:blipFill>
-        <p:spPr>
-          <a:xfrm>
-            <a:off x="4572000" y="960004"/>
-            <a:ext cx="3073348" cy="3073348"/>
-          </a:xfrm>
-          <a:prstGeom prst="rect">
-            <a:avLst/>
-          </a:prstGeom>
-          <a:noFill/>
-          <a:ln>
-            <a:noFill/>
-          </a:ln>
-        </p:spPr>
-      </p:pic>
-    </p:spTree>
-  </p:cSld>
-  <p:clrMapOvr>
-    <a:masterClrMapping/>
-  </p:clrMapOvr>
-</p:sld>
-</file>
-
-<file path=ppt/slides/slide3.xml><?xml version="1.0" encoding="utf-8"?>
-<p:sld xmlns:a="http://schemas.openxmlformats.org/drawingml/2006/main" xmlns:r="http://schemas.openxmlformats.org/officeDocument/2006/relationships" xmlns:mc="http://schemas.openxmlformats.org/markup-compatibility/2006" xmlns:mv="urn:schemas-microsoft-com:mac:vml" xmlns:p="http://schemas.openxmlformats.org/presentationml/2006/main" xmlns:c="http://schemas.openxmlformats.org/drawingml/2006/chart" xmlns:dgm="http://schemas.openxmlformats.org/drawingml/2006/diagram" xmlns:o="urn:schemas-microsoft-com:office:office" xmlns:v="urn:schemas-microsoft-com:vml" xmlns:pvml="urn:schemas-microsoft-com:office:powerpoint" xmlns:com="http://schemas.openxmlformats.org/drawingml/2006/compatibility" xmlns:p14="http://schemas.microsoft.com/office/powerpoint/2010/main" xmlns:p15="http://schemas.microsoft.com/office/powerpoint/2012/main" xmlns:ahyp="http://schemas.microsoft.com/office/drawing/2018/hyperlinkcolor">
-  <p:cSld>
-    <p:spTree>
-      <p:nvGrpSpPr>
-        <p:cNvPr id="76" name="Shape 76"/>
-        <p:cNvGrpSpPr/>
-        <p:nvPr/>
-      </p:nvGrpSpPr>
-      <p:grpSpPr>
-        <a:xfrm>
-          <a:off x="0" y="0"/>
-          <a:ext cx="0" cy="0"/>
-          <a:chOff x="0" y="0"/>
-          <a:chExt cx="0" cy="0"/>
-        </a:xfrm>
-      </p:grpSpPr>
-      <p:sp>
-        <p:nvSpPr>
-          <p:cNvPr id="77" name="Google Shape;77;p14"/>
-          <p:cNvSpPr txBox="1"/>
-          <p:nvPr>
-            <p:ph idx="1" type="subTitle"/>
-          </p:nvPr>
-        </p:nvSpPr>
-        <p:spPr>
-          <a:xfrm>
-            <a:off x="-12" y="845919"/>
-            <a:ext cx="5033100" cy="2379900"/>
-          </a:xfrm>
-          <a:prstGeom prst="rect">
-            <a:avLst/>
-          </a:prstGeom>
-          <a:noFill/>
-          <a:ln>
-            <a:noFill/>
-          </a:ln>
-        </p:spPr>
-        <p:txBody>
-          <a:bodyPr anchorCtr="0" anchor="t" bIns="91400" lIns="91400" spcFirstLastPara="1" rIns="91400" wrap="square" tIns="91400">
-            <a:noAutofit/>
-          </a:bodyPr>
-          <a:lstStyle/>
-          <a:p>
-            <a:pPr indent="-342900" lvl="0" marL="457200" rtl="0" algn="l">
-              <a:lnSpc>
-                <a:spcPct val="100000"/>
-              </a:lnSpc>
-              <a:spcBef>
-                <a:spcPts val="0"/>
-              </a:spcBef>
-              <a:spcAft>
-                <a:spcPts val="0"/>
-              </a:spcAft>
-              <a:buClr>
-                <a:schemeClr val="dk1"/>
-              </a:buClr>
-              <a:buSzPts val="3000"/>
-              <a:buFont typeface="Arial"/>
-              <a:buChar char="•"/>
-            </a:pPr>
-            <a:r>
-              <a:rPr b="1" i="0" lang="az-Latn-AZ" sz="700" u="none">
-                <a:solidFill>
-                  <a:srgbClr val="000000"/>
-                </a:solidFill>
-                <a:latin typeface="Times New Roman"/>
-                <a:ea typeface="Times New Roman"/>
-                <a:cs typeface="Times New Roman"/>
-                <a:sym typeface="Times New Roman"/>
-              </a:rPr>
-              <a:t> </a:t>
-            </a:r>
-            <a:r>
-              <a:rPr b="1" i="0" lang="az-Latn-AZ" sz="2000" u="none" cap="none" strike="noStrike">
-                <a:solidFill>
-                  <a:schemeClr val="dk1"/>
-                </a:solidFill>
-                <a:latin typeface="Vidaloka"/>
-                <a:ea typeface="Vidaloka"/>
-                <a:cs typeface="Vidaloka"/>
-                <a:sym typeface="Vidaloka"/>
-              </a:rPr>
-              <a:t>Biz bu sistemi tətbiq etməkdə əsas məqsədimiz, şagirdlərin dərsə iştirakının qeydiyyat prosesini tamamilə avtomatlaşdırmaq və bununla da məktəb heyətinin inzibati yükünü əhəmiyyətli dərəcədə azaltmaqdır</a:t>
-            </a:r>
-            <a:r>
-              <a:rPr b="1" i="0" lang="az-Latn-AZ" sz="700" u="none">
-                <a:solidFill>
-                  <a:srgbClr val="000000"/>
-                </a:solidFill>
-                <a:latin typeface="Times New Roman"/>
-                <a:ea typeface="Times New Roman"/>
-                <a:cs typeface="Times New Roman"/>
-                <a:sym typeface="Times New Roman"/>
-              </a:rPr>
-              <a:t>.</a:t>
-            </a:r>
-            <a:endParaRPr b="1" sz="800"/>
-          </a:p>
-        </p:txBody>
-      </p:sp>
-      <p:sp>
-        <p:nvSpPr>
-          <p:cNvPr id="78" name="Google Shape;78;p14"/>
-          <p:cNvSpPr txBox="1"/>
-          <p:nvPr>
-            <p:ph type="title"/>
-          </p:nvPr>
-        </p:nvSpPr>
-        <p:spPr>
-          <a:xfrm>
-            <a:off x="0" y="273225"/>
-            <a:ext cx="9144000" cy="572700"/>
-          </a:xfrm>
-          <a:prstGeom prst="rect">
-            <a:avLst/>
-          </a:prstGeom>
-          <a:noFill/>
-          <a:ln>
-            <a:noFill/>
-          </a:ln>
-        </p:spPr>
-        <p:txBody>
-          <a:bodyPr anchorCtr="0" anchor="t" bIns="91425" lIns="91425" spcFirstLastPara="1" rIns="91425" wrap="square" tIns="91425">
-            <a:noAutofit/>
-          </a:bodyPr>
-          <a:lstStyle/>
-          <a:p>
-            <a:pPr indent="0" lvl="0" marL="0" rtl="0" algn="ctr">
-              <a:lnSpc>
-                <a:spcPct val="100000"/>
-              </a:lnSpc>
-              <a:spcBef>
-                <a:spcPts val="0"/>
-              </a:spcBef>
-              <a:spcAft>
-                <a:spcPts val="0"/>
-              </a:spcAft>
-              <a:buSzPts val="3000"/>
-              <a:buNone/>
-            </a:pPr>
-            <a:r>
-              <a:rPr lang="az-Latn-AZ"/>
-              <a:t>Biz bunu niyə edirik?</a:t>
-            </a:r>
-            <a:endParaRPr/>
-          </a:p>
-        </p:txBody>
-      </p:sp>
-      <p:sp>
-        <p:nvSpPr>
-          <p:cNvPr id="79" name="Google Shape;79;p14"/>
-          <p:cNvSpPr txBox="1"/>
-          <p:nvPr/>
-        </p:nvSpPr>
-        <p:spPr>
-          <a:xfrm>
-            <a:off x="5618450" y="1212625"/>
-            <a:ext cx="3546900" cy="461700"/>
-          </a:xfrm>
-          <a:prstGeom prst="rect">
-            <a:avLst/>
-          </a:prstGeom>
-          <a:noFill/>
-          <a:ln>
-            <a:noFill/>
-          </a:ln>
-        </p:spPr>
-        <p:txBody>
-          <a:bodyPr anchorCtr="0" anchor="t" bIns="91425" lIns="91425" spcFirstLastPara="1" rIns="91425" wrap="square" tIns="91425">
-            <a:spAutoFit/>
-          </a:bodyPr>
-          <a:lstStyle/>
-          <a:p>
-            <a:pPr indent="0" lvl="0" marL="0" marR="0" rtl="0" algn="l">
-              <a:lnSpc>
-                <a:spcPct val="100000"/>
-              </a:lnSpc>
-              <a:spcBef>
-                <a:spcPts val="0"/>
-              </a:spcBef>
-              <a:spcAft>
-                <a:spcPts val="0"/>
-              </a:spcAft>
-              <a:buClr>
-                <a:srgbClr val="000000"/>
-              </a:buClr>
-              <a:buSzPts val="1800"/>
-              <a:buFont typeface="Arial"/>
-              <a:buNone/>
-            </a:pPr>
-            <a:r>
-              <a:t/>
-            </a:r>
-            <a:endParaRPr b="0" i="0" sz="1800" u="none" cap="none" strike="noStrike">
-              <a:solidFill>
-                <a:schemeClr val="dk2"/>
-              </a:solidFill>
-              <a:latin typeface="Montserrat"/>
-              <a:ea typeface="Montserrat"/>
-              <a:cs typeface="Montserrat"/>
-              <a:sym typeface="Montserrat"/>
-            </a:endParaRPr>
-          </a:p>
-        </p:txBody>
-      </p:sp>
-      <p:sp>
-        <p:nvSpPr>
-          <p:cNvPr id="80" name="Google Shape;80;p14"/>
-          <p:cNvSpPr txBox="1"/>
-          <p:nvPr/>
-        </p:nvSpPr>
-        <p:spPr>
-          <a:xfrm>
-            <a:off x="4664199" y="845921"/>
-            <a:ext cx="3638400" cy="2216400"/>
-          </a:xfrm>
-          <a:prstGeom prst="rect">
-            <a:avLst/>
-          </a:prstGeom>
-          <a:noFill/>
-          <a:ln>
-            <a:noFill/>
-          </a:ln>
-        </p:spPr>
-        <p:txBody>
-          <a:bodyPr anchorCtr="0" anchor="t" bIns="45700" lIns="91425" spcFirstLastPara="1" rIns="91425" wrap="square" tIns="45700">
-            <a:spAutoFit/>
-          </a:bodyPr>
-          <a:lstStyle/>
-          <a:p>
-            <a:pPr indent="-342900" lvl="0" marL="457200" marR="0" rtl="0" algn="l">
-              <a:lnSpc>
-                <a:spcPct val="100000"/>
-              </a:lnSpc>
-              <a:spcBef>
-                <a:spcPts val="0"/>
-              </a:spcBef>
-              <a:spcAft>
-                <a:spcPts val="0"/>
-              </a:spcAft>
-              <a:buClr>
-                <a:schemeClr val="dk1"/>
-              </a:buClr>
-              <a:buSzPts val="3000"/>
-              <a:buChar char="•"/>
-            </a:pPr>
-            <a:r>
-              <a:rPr b="1" i="0" lang="az-Latn-AZ" sz="1800" u="none" cap="none" strike="noStrike"/>
-              <a:t>Bu ağıllı proqram təminatı ilə məktəbiniz daha təhlükəsiz, müəllimlər isə daha az yüklənmiş olacaq!</a:t>
-            </a:r>
-            <a:r>
-              <a:rPr b="1" lang="az-Latn-AZ" sz="1800"/>
-              <a:t> </a:t>
-            </a:r>
-            <a:r>
-              <a:rPr b="1" i="0" lang="az-Latn-AZ" sz="1800" u="none" cap="none" strike="noStrike"/>
-              <a:t>jurnal yazmaq üçün sərf olunan vaxt isə xeyli qısalır. </a:t>
-            </a:r>
-            <a:endParaRPr b="1" i="0" sz="1800" u="none" cap="none" strike="noStrike">
-              <a:solidFill>
-                <a:srgbClr val="000000"/>
-              </a:solidFill>
+              <a:latin typeface="Montserrat Medium"/>
+              <a:ea typeface="Montserrat Medium"/>
+              <a:cs typeface="Montserrat Medium"/>
+              <a:sym typeface="Montserrat Medium"/>
             </a:endParaRPr>
           </a:p>
         </p:txBody>
@@ -6451,7 +6457,7 @@
   <p:cSld>
     <p:spTree>
       <p:nvGrpSpPr>
-        <p:cNvPr id="84" name="Shape 84"/>
+        <p:cNvPr id="83" name="Shape 83"/>
         <p:cNvGrpSpPr/>
         <p:nvPr/>
       </p:nvGrpSpPr>
@@ -6465,7 +6471,7 @@
       </p:grpSpPr>
       <p:sp>
         <p:nvSpPr>
-          <p:cNvPr id="85" name="Google Shape;85;p15"/>
+          <p:cNvPr id="84" name="Google Shape;84;p15"/>
           <p:cNvSpPr txBox="1"/>
           <p:nvPr>
             <p:ph type="title"/>
@@ -6504,16 +6510,26 @@
               <a:buNone/>
             </a:pPr>
             <a:r>
-              <a:rPr lang="az-Latn-AZ"/>
+              <a:rPr b="1" lang="az-Latn-AZ">
+                <a:latin typeface="Montserrat"/>
+                <a:ea typeface="Montserrat"/>
+                <a:cs typeface="Montserrat"/>
+                <a:sym typeface="Montserrat"/>
+              </a:rPr>
               <a:t>Asanlıq!</a:t>
             </a:r>
-            <a:endParaRPr/>
+            <a:endParaRPr b="1">
+              <a:latin typeface="Montserrat"/>
+              <a:ea typeface="Montserrat"/>
+              <a:cs typeface="Montserrat"/>
+              <a:sym typeface="Montserrat"/>
+            </a:endParaRPr>
           </a:p>
         </p:txBody>
       </p:sp>
       <p:sp>
         <p:nvSpPr>
-          <p:cNvPr id="86" name="Google Shape;86;p15"/>
+          <p:cNvPr id="85" name="Google Shape;85;p15"/>
           <p:cNvSpPr txBox="1"/>
           <p:nvPr>
             <p:ph idx="1" type="subTitle"/>
@@ -6521,8 +6537,8 @@
         </p:nvSpPr>
         <p:spPr>
           <a:xfrm>
-            <a:off x="-68447" y="1455149"/>
-            <a:ext cx="4391100" cy="1965000"/>
+            <a:off x="-68450" y="1455150"/>
+            <a:ext cx="4391100" cy="1839000"/>
           </a:xfrm>
           <a:prstGeom prst="rect">
             <a:avLst/>
@@ -6538,7 +6554,7 @@
           </a:bodyPr>
           <a:lstStyle/>
           <a:p>
-            <a:pPr indent="-217793" lvl="0" marL="217793" marR="0" rtl="0" algn="ctr">
+            <a:pPr indent="-205093" lvl="0" marL="217793" marR="0" rtl="0" algn="ctr">
               <a:lnSpc>
                 <a:spcPct val="100000"/>
               </a:lnSpc>
@@ -6551,33 +6567,43 @@
               <a:buClr>
                 <a:schemeClr val="dk2"/>
               </a:buClr>
-              <a:buSzPts val="1800"/>
+              <a:buSzPts val="1600"/>
               <a:buFont typeface="Arial"/>
               <a:buChar char="•"/>
             </a:pPr>
             <a:r>
-              <a:rPr b="1" lang="az-Latn-AZ" sz="1600"/>
+              <a:rPr lang="az-Latn-AZ" sz="1600">
+                <a:latin typeface="Montserrat Medium"/>
+                <a:ea typeface="Montserrat Medium"/>
+                <a:cs typeface="Montserrat Medium"/>
+                <a:sym typeface="Montserrat Medium"/>
+              </a:rPr>
               <a:t>Bu, intuitiv interfeysə malik olub, istifadəçi dostu şəkildə dizayn edilmiş Qrafik İstifadəçi İnterfeysidir (GUI). Bu sistemin istifadəsi minimum təlimlə, hətta texniki bilikləri olmayanlar üçün də son dərəcə asandır</a:t>
             </a:r>
             <a:r>
-              <a:rPr b="1" lang="az-Latn-AZ" sz="1400">
+              <a:rPr lang="az-Latn-AZ" sz="1600">
                 <a:solidFill>
                   <a:srgbClr val="000000"/>
                 </a:solidFill>
-                <a:latin typeface="Times New Roman"/>
-                <a:ea typeface="Times New Roman"/>
-                <a:cs typeface="Times New Roman"/>
-                <a:sym typeface="Times New Roman"/>
+                <a:latin typeface="Montserrat Medium"/>
+                <a:ea typeface="Montserrat Medium"/>
+                <a:cs typeface="Montserrat Medium"/>
+                <a:sym typeface="Montserrat Medium"/>
               </a:rPr>
               <a:t>.</a:t>
             </a:r>
-            <a:endParaRPr b="1" sz="1600"/>
+            <a:endParaRPr sz="1600">
+              <a:latin typeface="Montserrat Medium"/>
+              <a:ea typeface="Montserrat Medium"/>
+              <a:cs typeface="Montserrat Medium"/>
+              <a:sym typeface="Montserrat Medium"/>
+            </a:endParaRPr>
           </a:p>
         </p:txBody>
       </p:sp>
       <p:pic>
         <p:nvPicPr>
-          <p:cNvPr id="87" name="Google Shape;87;p15"/>
+          <p:cNvPr id="86" name="Google Shape;86;p15"/>
           <p:cNvPicPr preferRelativeResize="0"/>
           <p:nvPr/>
         </p:nvPicPr>
@@ -6604,7 +6630,7 @@
       </p:pic>
       <p:sp>
         <p:nvSpPr>
-          <p:cNvPr id="88" name="Google Shape;88;p15"/>
+          <p:cNvPr id="87" name="Google Shape;87;p15"/>
           <p:cNvSpPr txBox="1"/>
           <p:nvPr/>
         </p:nvSpPr>
@@ -6641,16 +6667,29 @@
                 <a:schemeClr val="dk2"/>
               </a:buClr>
               <a:buSzPts val="1800"/>
+              <a:buFont typeface="Montserrat Medium"/>
               <a:buChar char="•"/>
             </a:pPr>
             <a:r>
-              <a:rPr b="1" i="0" lang="az-Latn-AZ" sz="1600" u="none" cap="none" strike="noStrike"/>
+              <a:rPr i="0" lang="az-Latn-AZ" sz="1600" u="none" cap="none" strike="noStrike">
+                <a:solidFill>
+                  <a:srgbClr val="000000"/>
+                </a:solidFill>
+                <a:latin typeface="Montserrat Medium"/>
+                <a:ea typeface="Montserrat Medium"/>
+                <a:cs typeface="Montserrat Medium"/>
+                <a:sym typeface="Montserrat Medium"/>
+              </a:rPr>
               <a:t>İstifadə rahatlığı sayəsində sistem hər yaşda və hər texnoloji səviyyədə olan müəllimlər üçün əlçatan olur. Sadə interfeys dərs prosesini sürətləndirir və müəllimlərə daha çox vaxtı tədrisə ayırmaq imkanı yaradır.</a:t>
             </a:r>
-            <a:endParaRPr b="1" i="0" sz="1600" u="none" cap="none" strike="noStrike">
+            <a:endParaRPr i="0" sz="1600" u="none" cap="none" strike="noStrike">
               <a:solidFill>
                 <a:srgbClr val="000000"/>
               </a:solidFill>
+              <a:latin typeface="Montserrat Medium"/>
+              <a:ea typeface="Montserrat Medium"/>
+              <a:cs typeface="Montserrat Medium"/>
+              <a:sym typeface="Montserrat Medium"/>
             </a:endParaRPr>
           </a:p>
         </p:txBody>
@@ -6668,7 +6707,7 @@
   <p:cSld>
     <p:spTree>
       <p:nvGrpSpPr>
-        <p:cNvPr id="93" name="Shape 93"/>
+        <p:cNvPr id="92" name="Shape 92"/>
         <p:cNvGrpSpPr/>
         <p:nvPr/>
       </p:nvGrpSpPr>
@@ -6682,7 +6721,7 @@
       </p:grpSpPr>
       <p:sp>
         <p:nvSpPr>
-          <p:cNvPr id="94" name="Google Shape;94;p16"/>
+          <p:cNvPr id="93" name="Google Shape;93;p16"/>
           <p:cNvSpPr txBox="1"/>
           <p:nvPr>
             <p:ph type="title"/>
@@ -6690,7 +6729,7 @@
         </p:nvSpPr>
         <p:spPr>
           <a:xfrm>
-            <a:off x="4647000" y="271950"/>
+            <a:off x="4548000" y="292175"/>
             <a:ext cx="4512900" cy="1291200"/>
           </a:xfrm>
           <a:prstGeom prst="rect">
@@ -6721,16 +6760,26 @@
               <a:buNone/>
             </a:pPr>
             <a:r>
-              <a:rPr lang="az-Latn-AZ"/>
+              <a:rPr b="1" lang="az-Latn-AZ">
+                <a:latin typeface="Montserrat"/>
+                <a:ea typeface="Montserrat"/>
+                <a:cs typeface="Montserrat"/>
+                <a:sym typeface="Montserrat"/>
+              </a:rPr>
               <a:t>Sürət!</a:t>
             </a:r>
-            <a:endParaRPr/>
+            <a:endParaRPr b="1">
+              <a:latin typeface="Montserrat"/>
+              <a:ea typeface="Montserrat"/>
+              <a:cs typeface="Montserrat"/>
+              <a:sym typeface="Montserrat"/>
+            </a:endParaRPr>
           </a:p>
         </p:txBody>
       </p:sp>
       <p:sp>
         <p:nvSpPr>
-          <p:cNvPr id="95" name="Google Shape;95;p16"/>
+          <p:cNvPr id="94" name="Google Shape;94;p16"/>
           <p:cNvSpPr txBox="1"/>
           <p:nvPr>
             <p:ph idx="1" type="subTitle"/>
@@ -6738,8 +6787,8 @@
         </p:nvSpPr>
         <p:spPr>
           <a:xfrm>
-            <a:off x="4630962" y="1430413"/>
-            <a:ext cx="4545000" cy="927600"/>
+            <a:off x="4372974" y="1430425"/>
+            <a:ext cx="4803000" cy="927600"/>
           </a:xfrm>
           <a:prstGeom prst="rect">
             <a:avLst/>
@@ -6773,40 +6822,26 @@
               <a:buNone/>
             </a:pPr>
             <a:r>
-              <a:rPr b="0" i="0" lang="az-Latn-AZ" sz="1200" u="none" cap="none" strike="noStrike">
-                <a:solidFill>
-                  <a:schemeClr val="dk2"/>
-                </a:solidFill>
-                <a:latin typeface="Montserrat"/>
-                <a:ea typeface="Montserrat"/>
-                <a:cs typeface="Montserrat"/>
-                <a:sym typeface="Montserrat"/>
+              <a:rPr lang="az-Latn-AZ" sz="1600">
+                <a:latin typeface="Montserrat Medium"/>
+                <a:ea typeface="Montserrat Medium"/>
+                <a:cs typeface="Montserrat Medium"/>
+                <a:sym typeface="Montserrat Medium"/>
               </a:rPr>
-              <a:t>Artıq jurnal yerinə elektron sistemdən istifadə olunur, ona görə də bütün məlumatlar birbaşa m</a:t>
+              <a:t>Ağıllı davamiyyət sistemi hər halda ənənəvi jurnaldan daha sürətli və daha dəqiqdir</a:t>
             </a:r>
-            <a:r>
-              <a:rPr lang="az-Latn-AZ" sz="1200"/>
-              <a:t>əktəb </a:t>
-            </a:r>
-            <a:r>
-              <a:rPr b="0" i="0" lang="az-Latn-AZ" sz="1200" u="none" cap="none" strike="noStrike">
-                <a:solidFill>
-                  <a:schemeClr val="dk2"/>
-                </a:solidFill>
-                <a:latin typeface="Montserrat"/>
-                <a:ea typeface="Montserrat"/>
-                <a:cs typeface="Montserrat"/>
-                <a:sym typeface="Montserrat"/>
-              </a:rPr>
-              <a:t>direktorun kompüterinə gedəcək.</a:t>
-            </a:r>
-            <a:endParaRPr sz="1200"/>
+            <a:endParaRPr sz="1600">
+              <a:latin typeface="Montserrat Medium"/>
+              <a:ea typeface="Montserrat Medium"/>
+              <a:cs typeface="Montserrat Medium"/>
+              <a:sym typeface="Montserrat Medium"/>
+            </a:endParaRPr>
           </a:p>
         </p:txBody>
       </p:sp>
       <p:pic>
         <p:nvPicPr>
-          <p:cNvPr id="96" name="Google Shape;96;p16"/>
+          <p:cNvPr id="95" name="Google Shape;95;p16"/>
           <p:cNvPicPr preferRelativeResize="0"/>
           <p:nvPr/>
         </p:nvPicPr>
@@ -6819,8 +6854,8 @@
         </p:blipFill>
         <p:spPr>
           <a:xfrm>
-            <a:off x="157974" y="431331"/>
-            <a:ext cx="4233170" cy="4280835"/>
+            <a:off x="157975" y="449705"/>
+            <a:ext cx="4214999" cy="4262471"/>
           </a:xfrm>
           <a:prstGeom prst="rect">
             <a:avLst/>
@@ -6833,14 +6868,14 @@
       </p:pic>
       <p:sp>
         <p:nvSpPr>
-          <p:cNvPr id="97" name="Google Shape;97;p16"/>
+          <p:cNvPr id="96" name="Google Shape;96;p16"/>
           <p:cNvSpPr txBox="1"/>
           <p:nvPr/>
         </p:nvSpPr>
         <p:spPr>
           <a:xfrm>
-            <a:off x="5226000" y="2028475"/>
-            <a:ext cx="3354900" cy="954300"/>
+            <a:off x="5127000" y="2140800"/>
+            <a:ext cx="3354900" cy="861900"/>
           </a:xfrm>
           <a:prstGeom prst="rect">
             <a:avLst/>
@@ -6874,18 +6909,18 @@
               <a:buNone/>
             </a:pPr>
             <a:r>
-              <a:rPr b="0" i="0" lang="az-Latn-AZ" sz="5000" u="none" cap="none" strike="noStrike">
+              <a:rPr b="1" i="0" lang="az-Latn-AZ" sz="4400" u="none" cap="none" strike="noStrike">
                 <a:solidFill>
                   <a:schemeClr val="dk1"/>
                 </a:solidFill>
-                <a:latin typeface="Vidaloka"/>
-                <a:ea typeface="Vidaloka"/>
-                <a:cs typeface="Vidaloka"/>
-                <a:sym typeface="Vidaloka"/>
+                <a:latin typeface="Montserrat"/>
+                <a:ea typeface="Montserrat"/>
+                <a:cs typeface="Montserrat"/>
+                <a:sym typeface="Montserrat"/>
               </a:rPr>
               <a:t>TechStack</a:t>
             </a:r>
-            <a:endParaRPr b="0" i="0" sz="5000" u="none" cap="none" strike="noStrike">
+            <a:endParaRPr b="1" i="0" sz="4400" u="none" cap="none" strike="noStrike">
               <a:solidFill>
                 <a:schemeClr val="dk2"/>
               </a:solidFill>
@@ -6899,14 +6934,14 @@
       </p:sp>
       <p:sp>
         <p:nvSpPr>
-          <p:cNvPr id="98" name="Google Shape;98;p16"/>
+          <p:cNvPr id="97" name="Google Shape;97;p16"/>
           <p:cNvSpPr txBox="1"/>
           <p:nvPr/>
         </p:nvSpPr>
         <p:spPr>
           <a:xfrm>
             <a:off x="4647000" y="2982775"/>
-            <a:ext cx="4314900" cy="338700"/>
+            <a:ext cx="4314900" cy="354000"/>
           </a:xfrm>
           <a:prstGeom prst="rect">
             <a:avLst/>
@@ -6940,32 +6975,32 @@
               <a:buNone/>
             </a:pPr>
             <a:r>
-              <a:rPr b="1" i="0" lang="az-Latn-AZ" sz="1000" u="none" cap="none" strike="noStrike">
+              <a:rPr i="0" lang="az-Latn-AZ" sz="1100" u="none" cap="none" strike="noStrike">
                 <a:solidFill>
                   <a:schemeClr val="dk2"/>
                 </a:solidFill>
-                <a:latin typeface="Montserrat"/>
-                <a:ea typeface="Montserrat"/>
-                <a:cs typeface="Montserrat"/>
-                <a:sym typeface="Montserrat"/>
+                <a:latin typeface="Montserrat SemiBold"/>
+                <a:ea typeface="Montserrat SemiBold"/>
+                <a:cs typeface="Montserrat SemiBold"/>
+                <a:sym typeface="Montserrat SemiBold"/>
               </a:rPr>
               <a:t>Proqram üçün əsasən Python dilindən istifadə olunub.</a:t>
             </a:r>
-            <a:endParaRPr b="1" i="0" sz="1000" u="none" cap="none" strike="noStrike">
+            <a:endParaRPr i="0" sz="1100" u="none" cap="none" strike="noStrike">
               <a:solidFill>
                 <a:schemeClr val="dk2"/>
               </a:solidFill>
-              <a:latin typeface="Montserrat"/>
-              <a:ea typeface="Montserrat"/>
-              <a:cs typeface="Montserrat"/>
-              <a:sym typeface="Montserrat"/>
+              <a:latin typeface="Montserrat SemiBold"/>
+              <a:ea typeface="Montserrat SemiBold"/>
+              <a:cs typeface="Montserrat SemiBold"/>
+              <a:sym typeface="Montserrat SemiBold"/>
             </a:endParaRPr>
           </a:p>
         </p:txBody>
       </p:sp>
       <p:sp>
         <p:nvSpPr>
-          <p:cNvPr id="99" name="Google Shape;99;p16"/>
+          <p:cNvPr id="98" name="Google Shape;98;p16"/>
           <p:cNvSpPr txBox="1"/>
           <p:nvPr/>
         </p:nvSpPr>
@@ -7002,29 +7037,29 @@
                 <a:schemeClr val="dk2"/>
               </a:buClr>
               <a:buSzPts val="1000"/>
-              <a:buFont typeface="Montserrat"/>
+              <a:buFont typeface="Montserrat Medium"/>
               <a:buChar char="●"/>
             </a:pPr>
             <a:r>
-              <a:rPr b="1" i="0" lang="az-Latn-AZ" sz="1000" u="none" cap="none" strike="noStrike">
+              <a:rPr i="0" lang="az-Latn-AZ" sz="1000" u="none" cap="none" strike="noStrike">
                 <a:solidFill>
                   <a:schemeClr val="dk2"/>
                 </a:solidFill>
-                <a:latin typeface="Montserrat"/>
-                <a:ea typeface="Montserrat"/>
-                <a:cs typeface="Montserrat"/>
-                <a:sym typeface="Montserrat"/>
+                <a:latin typeface="Montserrat Medium"/>
+                <a:ea typeface="Montserrat Medium"/>
+                <a:cs typeface="Montserrat Medium"/>
+                <a:sym typeface="Montserrat Medium"/>
               </a:rPr>
               <a:t>OpenCV-Python: Kamera və görüntü emalı üçün.</a:t>
             </a:r>
-            <a:endParaRPr b="1" i="0" sz="1000" u="none" cap="none" strike="noStrike">
+            <a:endParaRPr i="0" sz="1000" u="none" cap="none" strike="noStrike">
               <a:solidFill>
                 <a:schemeClr val="dk2"/>
               </a:solidFill>
-              <a:latin typeface="Montserrat"/>
-              <a:ea typeface="Montserrat"/>
-              <a:cs typeface="Montserrat"/>
-              <a:sym typeface="Montserrat"/>
+              <a:latin typeface="Montserrat Medium"/>
+              <a:ea typeface="Montserrat Medium"/>
+              <a:cs typeface="Montserrat Medium"/>
+              <a:sym typeface="Montserrat Medium"/>
             </a:endParaRPr>
           </a:p>
           <a:p>
@@ -7042,29 +7077,29 @@
                 <a:schemeClr val="dk2"/>
               </a:buClr>
               <a:buSzPts val="1000"/>
-              <a:buFont typeface="Montserrat"/>
+              <a:buFont typeface="Montserrat Medium"/>
               <a:buChar char="●"/>
             </a:pPr>
             <a:r>
-              <a:rPr b="1" i="0" lang="az-Latn-AZ" sz="1000" u="none" cap="none" strike="noStrike">
+              <a:rPr i="0" lang="az-Latn-AZ" sz="1000" u="none" cap="none" strike="noStrike">
                 <a:solidFill>
                   <a:schemeClr val="dk2"/>
                 </a:solidFill>
-                <a:latin typeface="Montserrat"/>
-                <a:ea typeface="Montserrat"/>
-                <a:cs typeface="Montserrat"/>
-                <a:sym typeface="Montserrat"/>
+                <a:latin typeface="Montserrat Medium"/>
+                <a:ea typeface="Montserrat Medium"/>
+                <a:cs typeface="Montserrat Medium"/>
+                <a:sym typeface="Montserrat Medium"/>
               </a:rPr>
               <a:t>NumPy: Tanıma prosesi və hesablama əməliyyatları üçün.</a:t>
             </a:r>
-            <a:endParaRPr b="1" i="0" sz="1000" u="none" cap="none" strike="noStrike">
+            <a:endParaRPr i="0" sz="1000" u="none" cap="none" strike="noStrike">
               <a:solidFill>
                 <a:schemeClr val="dk2"/>
               </a:solidFill>
-              <a:latin typeface="Montserrat"/>
-              <a:ea typeface="Montserrat"/>
-              <a:cs typeface="Montserrat"/>
-              <a:sym typeface="Montserrat"/>
+              <a:latin typeface="Montserrat Medium"/>
+              <a:ea typeface="Montserrat Medium"/>
+              <a:cs typeface="Montserrat Medium"/>
+              <a:sym typeface="Montserrat Medium"/>
             </a:endParaRPr>
           </a:p>
           <a:p>
@@ -7082,29 +7117,29 @@
                 <a:schemeClr val="dk2"/>
               </a:buClr>
               <a:buSzPts val="1000"/>
-              <a:buFont typeface="Montserrat"/>
+              <a:buFont typeface="Montserrat Medium"/>
               <a:buChar char="●"/>
             </a:pPr>
             <a:r>
-              <a:rPr b="1" i="0" lang="az-Latn-AZ" sz="1000" u="none" cap="none" strike="noStrike">
+              <a:rPr i="0" lang="az-Latn-AZ" sz="1000" u="none" cap="none" strike="noStrike">
                 <a:solidFill>
                   <a:schemeClr val="dk2"/>
                 </a:solidFill>
-                <a:latin typeface="Montserrat"/>
-                <a:ea typeface="Montserrat"/>
-                <a:cs typeface="Montserrat"/>
-                <a:sym typeface="Montserrat"/>
+                <a:latin typeface="Montserrat Medium"/>
+                <a:ea typeface="Montserrat Medium"/>
+                <a:cs typeface="Montserrat Medium"/>
+                <a:sym typeface="Montserrat Medium"/>
               </a:rPr>
               <a:t>DeepFace: Süni intellekt əsaslı üz tanıma və analiz üçün.</a:t>
             </a:r>
-            <a:endParaRPr b="1" i="0" sz="1000" u="none" cap="none" strike="noStrike">
+            <a:endParaRPr i="0" sz="1000" u="none" cap="none" strike="noStrike">
               <a:solidFill>
                 <a:schemeClr val="dk2"/>
               </a:solidFill>
-              <a:latin typeface="Montserrat"/>
-              <a:ea typeface="Montserrat"/>
-              <a:cs typeface="Montserrat"/>
-              <a:sym typeface="Montserrat"/>
+              <a:latin typeface="Montserrat Medium"/>
+              <a:ea typeface="Montserrat Medium"/>
+              <a:cs typeface="Montserrat Medium"/>
+              <a:sym typeface="Montserrat Medium"/>
             </a:endParaRPr>
           </a:p>
           <a:p>
@@ -7122,29 +7157,29 @@
                 <a:schemeClr val="dk2"/>
               </a:buClr>
               <a:buSzPts val="1000"/>
-              <a:buFont typeface="Montserrat"/>
+              <a:buFont typeface="Montserrat Medium"/>
               <a:buChar char="●"/>
             </a:pPr>
             <a:r>
-              <a:rPr b="1" i="0" lang="az-Latn-AZ" sz="1000" u="none" cap="none" strike="noStrike">
+              <a:rPr i="0" lang="az-Latn-AZ" sz="1000" u="none" cap="none" strike="noStrike">
                 <a:solidFill>
                   <a:schemeClr val="dk2"/>
                 </a:solidFill>
-                <a:latin typeface="Montserrat"/>
-                <a:ea typeface="Montserrat"/>
-                <a:cs typeface="Montserrat"/>
-                <a:sym typeface="Montserrat"/>
+                <a:latin typeface="Montserrat Medium"/>
+                <a:ea typeface="Montserrat Medium"/>
+                <a:cs typeface="Montserrat Medium"/>
+                <a:sym typeface="Montserrat Medium"/>
               </a:rPr>
               <a:t>TensorFlow &amp; Keras: GPU istifadə edərək sürətli dərin öyrənmə əməliyyatları üçün.</a:t>
             </a:r>
-            <a:endParaRPr b="1" i="0" sz="1000" u="none" cap="none" strike="noStrike">
+            <a:endParaRPr i="0" sz="1000" u="none" cap="none" strike="noStrike">
               <a:solidFill>
                 <a:schemeClr val="dk2"/>
               </a:solidFill>
-              <a:latin typeface="Montserrat"/>
-              <a:ea typeface="Montserrat"/>
-              <a:cs typeface="Montserrat"/>
-              <a:sym typeface="Montserrat"/>
+              <a:latin typeface="Montserrat Medium"/>
+              <a:ea typeface="Montserrat Medium"/>
+              <a:cs typeface="Montserrat Medium"/>
+              <a:sym typeface="Montserrat Medium"/>
             </a:endParaRPr>
           </a:p>
           <a:p>
@@ -7162,29 +7197,29 @@
                 <a:schemeClr val="dk2"/>
               </a:buClr>
               <a:buSzPts val="1000"/>
-              <a:buFont typeface="Montserrat"/>
+              <a:buFont typeface="Montserrat Medium"/>
               <a:buChar char="●"/>
             </a:pPr>
             <a:r>
-              <a:rPr b="1" i="0" lang="az-Latn-AZ" sz="1000" u="none" cap="none" strike="noStrike">
+              <a:rPr i="0" lang="az-Latn-AZ" sz="1000" u="none" cap="none" strike="noStrike">
                 <a:solidFill>
                   <a:schemeClr val="dk2"/>
                 </a:solidFill>
-                <a:latin typeface="Montserrat"/>
-                <a:ea typeface="Montserrat"/>
-                <a:cs typeface="Montserrat"/>
-                <a:sym typeface="Montserrat"/>
+                <a:latin typeface="Montserrat Medium"/>
+                <a:ea typeface="Montserrat Medium"/>
+                <a:cs typeface="Montserrat Medium"/>
+                <a:sym typeface="Montserrat Medium"/>
               </a:rPr>
               <a:t>Playsound: Səs fayllarını oxutmaq üçün.</a:t>
             </a:r>
-            <a:endParaRPr b="1" i="0" sz="1000" u="none" cap="none" strike="noStrike">
+            <a:endParaRPr i="0" sz="1000" u="none" cap="none" strike="noStrike">
               <a:solidFill>
                 <a:schemeClr val="dk2"/>
               </a:solidFill>
-              <a:latin typeface="Montserrat"/>
-              <a:ea typeface="Montserrat"/>
-              <a:cs typeface="Montserrat"/>
-              <a:sym typeface="Montserrat"/>
+              <a:latin typeface="Montserrat Medium"/>
+              <a:ea typeface="Montserrat Medium"/>
+              <a:cs typeface="Montserrat Medium"/>
+              <a:sym typeface="Montserrat Medium"/>
             </a:endParaRPr>
           </a:p>
           <a:p>
@@ -7202,29 +7237,29 @@
                 <a:schemeClr val="dk2"/>
               </a:buClr>
               <a:buSzPts val="1000"/>
-              <a:buFont typeface="Montserrat"/>
+              <a:buFont typeface="Montserrat Medium"/>
               <a:buChar char="●"/>
             </a:pPr>
             <a:r>
-              <a:rPr b="1" i="0" lang="az-Latn-AZ" sz="1000" u="none" cap="none" strike="noStrike">
+              <a:rPr i="0" lang="az-Latn-AZ" sz="1000" u="none" cap="none" strike="noStrike">
                 <a:solidFill>
                   <a:schemeClr val="dk2"/>
                 </a:solidFill>
-                <a:latin typeface="Montserrat"/>
-                <a:ea typeface="Montserrat"/>
-                <a:cs typeface="Montserrat"/>
-                <a:sym typeface="Montserrat"/>
+                <a:latin typeface="Montserrat Medium"/>
+                <a:ea typeface="Montserrat Medium"/>
+                <a:cs typeface="Montserrat Medium"/>
+                <a:sym typeface="Montserrat Medium"/>
               </a:rPr>
               <a:t>CustomTkinter: Modern və istifadəsi rahat istifadəçi interfeysi üçün.</a:t>
             </a:r>
-            <a:endParaRPr b="1" i="0" sz="1000" u="none" cap="none" strike="noStrike">
+            <a:endParaRPr i="0" sz="1000" u="none" cap="none" strike="noStrike">
               <a:solidFill>
                 <a:schemeClr val="dk2"/>
               </a:solidFill>
-              <a:latin typeface="Montserrat"/>
-              <a:ea typeface="Montserrat"/>
-              <a:cs typeface="Montserrat"/>
-              <a:sym typeface="Montserrat"/>
+              <a:latin typeface="Montserrat Medium"/>
+              <a:ea typeface="Montserrat Medium"/>
+              <a:cs typeface="Montserrat Medium"/>
+              <a:sym typeface="Montserrat Medium"/>
             </a:endParaRPr>
           </a:p>
         </p:txBody>
@@ -7242,7 +7277,7 @@
   <p:cSld>
     <p:spTree>
       <p:nvGrpSpPr>
-        <p:cNvPr id="104" name="Shape 104"/>
+        <p:cNvPr id="103" name="Shape 103"/>
         <p:cNvGrpSpPr/>
         <p:nvPr/>
       </p:nvGrpSpPr>
@@ -7256,7 +7291,7 @@
       </p:grpSpPr>
       <p:sp>
         <p:nvSpPr>
-          <p:cNvPr id="105" name="Google Shape;105;p17"/>
+          <p:cNvPr id="104" name="Google Shape;104;p17"/>
           <p:cNvSpPr txBox="1"/>
           <p:nvPr>
             <p:ph type="title"/>
@@ -7264,7 +7299,7 @@
         </p:nvSpPr>
         <p:spPr>
           <a:xfrm>
-            <a:off x="-180854" y="295928"/>
+            <a:off x="-53854" y="295928"/>
             <a:ext cx="5835900" cy="1291200"/>
           </a:xfrm>
           <a:prstGeom prst="rect">
@@ -7299,32 +7334,32 @@
               <a:buNone/>
             </a:pPr>
             <a:r>
-              <a:rPr b="0" i="0" lang="az-Latn-AZ" sz="7000" u="none" cap="none" strike="noStrike">
+              <a:rPr b="1" i="0" lang="az-Latn-AZ" sz="6000" u="none" cap="none" strike="noStrike">
                 <a:solidFill>
                   <a:schemeClr val="dk1"/>
                 </a:solidFill>
-                <a:latin typeface="Vidaloka"/>
-                <a:ea typeface="Vidaloka"/>
-                <a:cs typeface="Vidaloka"/>
-                <a:sym typeface="Vidaloka"/>
+                <a:latin typeface="Montserrat"/>
+                <a:ea typeface="Montserrat"/>
+                <a:cs typeface="Montserrat"/>
+                <a:sym typeface="Montserrat"/>
               </a:rPr>
               <a:t>Təhlükəsizlik!</a:t>
             </a:r>
-            <a:endParaRPr b="0" i="0" sz="7000" u="none" cap="none" strike="noStrike">
+            <a:endParaRPr b="1" i="0" sz="6000" u="none" cap="none" strike="noStrike">
               <a:solidFill>
                 <a:schemeClr val="dk1"/>
               </a:solidFill>
-              <a:latin typeface="Vidaloka"/>
-              <a:ea typeface="Vidaloka"/>
-              <a:cs typeface="Vidaloka"/>
-              <a:sym typeface="Vidaloka"/>
+              <a:latin typeface="Montserrat"/>
+              <a:ea typeface="Montserrat"/>
+              <a:cs typeface="Montserrat"/>
+              <a:sym typeface="Montserrat"/>
             </a:endParaRPr>
           </a:p>
         </p:txBody>
       </p:sp>
       <p:pic>
         <p:nvPicPr>
-          <p:cNvPr id="106" name="Google Shape;106;p17"/>
+          <p:cNvPr id="105" name="Google Shape;105;p17"/>
           <p:cNvPicPr preferRelativeResize="0"/>
           <p:nvPr/>
         </p:nvPicPr>
@@ -7337,7 +7372,7 @@
         </p:blipFill>
         <p:spPr>
           <a:xfrm>
-            <a:off x="5728290" y="805068"/>
+            <a:off x="5728190" y="1587118"/>
             <a:ext cx="3400062" cy="2353853"/>
           </a:xfrm>
           <a:prstGeom prst="rect">
@@ -7351,14 +7386,14 @@
       </p:pic>
       <p:sp>
         <p:nvSpPr>
-          <p:cNvPr id="107" name="Google Shape;107;p17"/>
+          <p:cNvPr id="106" name="Google Shape;106;p17"/>
           <p:cNvSpPr txBox="1"/>
           <p:nvPr/>
         </p:nvSpPr>
         <p:spPr>
           <a:xfrm>
-            <a:off x="0" y="1356900"/>
-            <a:ext cx="5728200" cy="3109200"/>
+            <a:off x="0" y="1417525"/>
+            <a:ext cx="5728200" cy="2893800"/>
           </a:xfrm>
           <a:prstGeom prst="rect">
             <a:avLst/>
@@ -7388,24 +7423,29 @@
                 <a:schemeClr val="dk2"/>
               </a:buClr>
               <a:buSzPts val="1400"/>
+              <a:buFont typeface="Montserrat Medium"/>
               <a:buChar char="•"/>
             </a:pPr>
             <a:r>
-              <a:rPr b="1" lang="az-Latn-AZ">
+              <a:rPr i="0" lang="az-Latn-AZ" u="none" cap="none" strike="noStrike">
                 <a:solidFill>
                   <a:schemeClr val="dk2"/>
                 </a:solidFill>
-                <a:latin typeface="Montserrat"/>
-                <a:ea typeface="Montserrat"/>
-                <a:cs typeface="Montserrat"/>
-                <a:sym typeface="Montserrat"/>
+                <a:latin typeface="Montserrat Medium"/>
+                <a:ea typeface="Montserrat Medium"/>
+                <a:cs typeface="Montserrat Medium"/>
+                <a:sym typeface="Montserrat Medium"/>
               </a:rPr>
               <a:t>Sistem məktəbin təhlükəsizlik kameralarına inteqrasiya olunduqda, kameralar vasitəsilə məktəbə daxil olan və məktəbə gəlməyən bütün şagirdləri avtomatik şəkildə tanıyır. Tanıma prosesi süni intellekt əsaslı üz tanıma texnologiyası ilə həyata keçirilir və bu sistem insan səhvinə yol vermədən 100% dəqiqliklə işləyir. Hər günün sonunda sistem bu məlumatları analiz edərək, kimlərin məktəbə gəldiyini, kimlərin gəlmədiyini və gəliş saatlarını qeyd edir. Toplanmış bütün məlumatlar avtomatik şəkildə Excel faylı formatında hazırlanır və məktəb direktorunun kompüterinə ötürülür. Direktor bu faylı açaraq, hər bir şagirdin davamiyyətini rahatlıqla izləyə, gün, həftə və ya ay üzrə hesabatlar əldə edə bilər.</a:t>
             </a:r>
-            <a:endParaRPr b="1" i="0" u="none" cap="none" strike="noStrike">
+            <a:endParaRPr i="0" u="none" cap="none" strike="noStrike">
               <a:solidFill>
                 <a:srgbClr val="000000"/>
               </a:solidFill>
+              <a:latin typeface="Montserrat Medium"/>
+              <a:ea typeface="Montserrat Medium"/>
+              <a:cs typeface="Montserrat Medium"/>
+              <a:sym typeface="Montserrat Medium"/>
             </a:endParaRPr>
           </a:p>
         </p:txBody>
@@ -7423,7 +7463,7 @@
   <p:cSld>
     <p:spTree>
       <p:nvGrpSpPr>
-        <p:cNvPr id="111" name="Shape 111"/>
+        <p:cNvPr id="110" name="Shape 110"/>
         <p:cNvGrpSpPr/>
         <p:nvPr/>
       </p:nvGrpSpPr>
@@ -7437,7 +7477,7 @@
       </p:grpSpPr>
       <p:sp>
         <p:nvSpPr>
-          <p:cNvPr id="112" name="Google Shape;112;p18"/>
+          <p:cNvPr id="111" name="Google Shape;111;p18"/>
           <p:cNvSpPr txBox="1"/>
           <p:nvPr>
             <p:ph type="ctrTitle"/>
@@ -7480,25 +7520,25 @@
               <a:buNone/>
             </a:pPr>
             <a:r>
-              <a:rPr b="0" i="0" lang="az-Latn-AZ" sz="6500" u="none" cap="none" strike="noStrike">
+              <a:rPr b="1" i="0" lang="az-Latn-AZ" sz="6500" u="none" cap="none" strike="noStrike">
                 <a:solidFill>
                   <a:schemeClr val="dk1"/>
                 </a:solidFill>
-                <a:latin typeface="Vidaloka"/>
-                <a:ea typeface="Vidaloka"/>
-                <a:cs typeface="Vidaloka"/>
-                <a:sym typeface="Vidaloka"/>
+                <a:latin typeface="Montserrat"/>
+                <a:ea typeface="Montserrat"/>
+                <a:cs typeface="Montserrat"/>
+                <a:sym typeface="Montserrat"/>
               </a:rPr>
               <a:t>Slaydın sonu</a:t>
             </a:r>
-            <a:endParaRPr b="0" i="0" sz="6500" u="none" cap="none" strike="noStrike">
+            <a:endParaRPr b="1" i="0" sz="6500" u="none" cap="none" strike="noStrike">
               <a:solidFill>
                 <a:schemeClr val="dk1"/>
               </a:solidFill>
-              <a:latin typeface="Vidaloka"/>
-              <a:ea typeface="Vidaloka"/>
-              <a:cs typeface="Vidaloka"/>
-              <a:sym typeface="Vidaloka"/>
+              <a:latin typeface="Montserrat"/>
+              <a:ea typeface="Montserrat"/>
+              <a:cs typeface="Montserrat"/>
+              <a:sym typeface="Montserrat"/>
             </a:endParaRPr>
           </a:p>
           <a:p>
@@ -7518,7 +7558,12 @@
             <a:r>
               <a:t/>
             </a:r>
-            <a:endParaRPr/>
+            <a:endParaRPr b="1">
+              <a:latin typeface="Montserrat"/>
+              <a:ea typeface="Montserrat"/>
+              <a:cs typeface="Montserrat"/>
+              <a:sym typeface="Montserrat"/>
+            </a:endParaRPr>
           </a:p>
         </p:txBody>
       </p:sp>

</xml_diff>